<commit_message>
Add submission deck, eval re-run with escalation path, lakh/month planner fixes
Co-Authored-By: Claude Fable 5.1 <noreply@anthropic.com>
</commit_message>
<xml_diff>
--- a/docs/deck.pptx
+++ b/docs/deck.pptx
@@ -2574,8 +2574,8 @@
         </p:nvSpPr>
         <p:spPr>
           <a:xfrm>
-            <a:off x="548640" y="1490472"/>
-            <a:ext cx="457200" cy="457200"/>
+            <a:off x="548640" y="1435608"/>
+            <a:ext cx="420624" cy="420624"/>
           </a:xfrm>
           <a:prstGeom prst="ellipse">
             <a:avLst/>
@@ -2594,8 +2594,8 @@
         </p:nvSpPr>
         <p:spPr>
           <a:xfrm>
-            <a:off x="548640" y="1490472"/>
-            <a:ext cx="457200" cy="457200"/>
+            <a:off x="548640" y="1435608"/>
+            <a:ext cx="420624" cy="420624"/>
           </a:xfrm>
           <a:prstGeom prst="rect">
             <a:avLst/>
@@ -2611,7 +2611,7 @@
               <a:buNone/>
             </a:pPr>
             <a:r>
-              <a:rPr lang="en-US" sz="1600" b="1" dirty="0">
+              <a:rPr lang="en-US" sz="1500" b="1" dirty="0">
                 <a:solidFill>
                   <a:srgbClr val="12163A"/>
                 </a:solidFill>
@@ -2621,7 +2621,7 @@
               </a:rPr>
               <a:t>1</a:t>
             </a:r>
-            <a:endParaRPr lang="en-US" sz="1600" dirty="0"/>
+            <a:endParaRPr lang="en-US" sz="1500" dirty="0"/>
           </a:p>
         </p:txBody>
       </p:sp>
@@ -2633,12 +2633,12 @@
         </p:nvSpPr>
         <p:spPr>
           <a:xfrm>
-            <a:off x="1188720" y="1417320"/>
-            <a:ext cx="10424160" cy="896112"/>
+            <a:off x="1170432" y="1371600"/>
+            <a:ext cx="10442448" cy="749808"/>
           </a:xfrm>
           <a:prstGeom prst="roundRect">
             <a:avLst>
-              <a:gd name="adj" fmla="val 9184"/>
+              <a:gd name="adj" fmla="val 10976"/>
             </a:avLst>
           </a:prstGeom>
           <a:solidFill>
@@ -2655,8 +2655,8 @@
         </p:nvSpPr>
         <p:spPr>
           <a:xfrm>
-            <a:off x="1417320" y="1490472"/>
-            <a:ext cx="10058400" cy="365760"/>
+            <a:off x="1399032" y="1435608"/>
+            <a:ext cx="10058400" cy="320040"/>
           </a:xfrm>
           <a:prstGeom prst="rect">
             <a:avLst/>
@@ -2672,7 +2672,7 @@
               <a:buNone/>
             </a:pPr>
             <a:r>
-              <a:rPr lang="en-US" sz="1400" b="1" dirty="0">
+              <a:rPr lang="en-US" sz="1350" b="1" dirty="0">
                 <a:solidFill>
                   <a:srgbClr val="F5F7FF"/>
                 </a:solidFill>
@@ -2682,7 +2682,7 @@
               </a:rPr>
               <a:t>“Which vendors did I pay the most last month?”</a:t>
             </a:r>
-            <a:endParaRPr lang="en-US" sz="1400" dirty="0"/>
+            <a:endParaRPr lang="en-US" sz="1350" dirty="0"/>
           </a:p>
         </p:txBody>
       </p:sp>
@@ -2694,8 +2694,8 @@
         </p:nvSpPr>
         <p:spPr>
           <a:xfrm>
-            <a:off x="1417320" y="1847088"/>
-            <a:ext cx="10058400" cy="411480"/>
+            <a:off x="1399032" y="1746504"/>
+            <a:ext cx="10058400" cy="347472"/>
           </a:xfrm>
           <a:prstGeom prst="rect">
             <a:avLst/>
@@ -2709,12 +2709,12 @@
           <a:p>
             <a:pPr indent="0" marL="0">
               <a:lnSpc>
-                <a:spcPct val="105000"/>
+                <a:spcPct val="102000"/>
               </a:lnSpc>
               <a:buNone/>
             </a:pPr>
             <a:r>
-              <a:rPr lang="en-US" sz="1150" dirty="0">
+              <a:rPr lang="en-US" sz="1100" dirty="0">
                 <a:solidFill>
                   <a:srgbClr val="CADCFC"/>
                 </a:solidFill>
@@ -2724,7 +2724,7 @@
               </a:rPr>
               <a:t>EMI BAJAJ FINANCE is highest at ₹13,73,25,576. Followed by LIC PREMIUM POLICY at ₹3,03,80,709.</a:t>
             </a:r>
-            <a:endParaRPr lang="en-US" sz="1150" dirty="0"/>
+            <a:endParaRPr lang="en-US" sz="1100" dirty="0"/>
           </a:p>
         </p:txBody>
       </p:sp>
@@ -2736,8 +2736,8 @@
         </p:nvSpPr>
         <p:spPr>
           <a:xfrm>
-            <a:off x="548640" y="2441448"/>
-            <a:ext cx="457200" cy="457200"/>
+            <a:off x="548640" y="2258568"/>
+            <a:ext cx="420624" cy="420624"/>
           </a:xfrm>
           <a:prstGeom prst="ellipse">
             <a:avLst/>
@@ -2756,8 +2756,8 @@
         </p:nvSpPr>
         <p:spPr>
           <a:xfrm>
-            <a:off x="548640" y="2441448"/>
-            <a:ext cx="457200" cy="457200"/>
+            <a:off x="548640" y="2258568"/>
+            <a:ext cx="420624" cy="420624"/>
           </a:xfrm>
           <a:prstGeom prst="rect">
             <a:avLst/>
@@ -2773,7 +2773,7 @@
               <a:buNone/>
             </a:pPr>
             <a:r>
-              <a:rPr lang="en-US" sz="1600" b="1" dirty="0">
+              <a:rPr lang="en-US" sz="1500" b="1" dirty="0">
                 <a:solidFill>
                   <a:srgbClr val="12163A"/>
                 </a:solidFill>
@@ -2783,7 +2783,7 @@
               </a:rPr>
               <a:t>2</a:t>
             </a:r>
-            <a:endParaRPr lang="en-US" sz="1600" dirty="0"/>
+            <a:endParaRPr lang="en-US" sz="1500" dirty="0"/>
           </a:p>
         </p:txBody>
       </p:sp>
@@ -2795,12 +2795,12 @@
         </p:nvSpPr>
         <p:spPr>
           <a:xfrm>
-            <a:off x="1188720" y="2368296"/>
-            <a:ext cx="10424160" cy="896112"/>
+            <a:off x="1170432" y="2194560"/>
+            <a:ext cx="10442448" cy="749808"/>
           </a:xfrm>
           <a:prstGeom prst="roundRect">
             <a:avLst>
-              <a:gd name="adj" fmla="val 9184"/>
+              <a:gd name="adj" fmla="val 10976"/>
             </a:avLst>
           </a:prstGeom>
           <a:solidFill>
@@ -2817,8 +2817,8 @@
         </p:nvSpPr>
         <p:spPr>
           <a:xfrm>
-            <a:off x="1417320" y="2441448"/>
-            <a:ext cx="10058400" cy="365760"/>
+            <a:off x="1399032" y="2258568"/>
+            <a:ext cx="10058400" cy="320040"/>
           </a:xfrm>
           <a:prstGeom prst="rect">
             <a:avLst/>
@@ -2834,7 +2834,7 @@
               <a:buNone/>
             </a:pPr>
             <a:r>
-              <a:rPr lang="en-US" sz="1400" b="1" dirty="0">
+              <a:rPr lang="en-US" sz="1350" b="1" dirty="0">
                 <a:solidFill>
                   <a:srgbClr val="F5F7FF"/>
                 </a:solidFill>
@@ -2844,7 +2844,7 @@
               </a:rPr>
               <a:t>Expand the SQL + evidence panel</a:t>
             </a:r>
-            <a:endParaRPr lang="en-US" sz="1400" dirty="0"/>
+            <a:endParaRPr lang="en-US" sz="1350" dirty="0"/>
           </a:p>
         </p:txBody>
       </p:sp>
@@ -2856,8 +2856,8 @@
         </p:nvSpPr>
         <p:spPr>
           <a:xfrm>
-            <a:off x="1417320" y="2798064"/>
-            <a:ext cx="10058400" cy="411480"/>
+            <a:off x="1399032" y="2569464"/>
+            <a:ext cx="10058400" cy="347472"/>
           </a:xfrm>
           <a:prstGeom prst="rect">
             <a:avLst/>
@@ -2871,12 +2871,12 @@
           <a:p>
             <a:pPr indent="0" marL="0">
               <a:lnSpc>
-                <a:spcPct val="105000"/>
+                <a:spcPct val="102000"/>
               </a:lnSpc>
               <a:buNone/>
             </a:pPr>
             <a:r>
-              <a:rPr lang="en-US" sz="1150" dirty="0">
+              <a:rPr lang="en-US" sz="1100" dirty="0">
                 <a:solidFill>
                   <a:srgbClr val="CADCFC"/>
                 </a:solidFill>
@@ -2886,7 +2886,7 @@
               </a:rPr>
               <a:t>The exact parameterised SQL, plus masked evidence rows (account_number → XXXXXX1922, utr_number → [redacted]).</a:t>
             </a:r>
-            <a:endParaRPr lang="en-US" sz="1150" dirty="0"/>
+            <a:endParaRPr lang="en-US" sz="1100" dirty="0"/>
           </a:p>
         </p:txBody>
       </p:sp>
@@ -2898,8 +2898,8 @@
         </p:nvSpPr>
         <p:spPr>
           <a:xfrm>
-            <a:off x="548640" y="3392424"/>
-            <a:ext cx="457200" cy="457200"/>
+            <a:off x="548640" y="3081528"/>
+            <a:ext cx="420624" cy="420624"/>
           </a:xfrm>
           <a:prstGeom prst="ellipse">
             <a:avLst/>
@@ -2918,8 +2918,8 @@
         </p:nvSpPr>
         <p:spPr>
           <a:xfrm>
-            <a:off x="548640" y="3392424"/>
-            <a:ext cx="457200" cy="457200"/>
+            <a:off x="548640" y="3081528"/>
+            <a:ext cx="420624" cy="420624"/>
           </a:xfrm>
           <a:prstGeom prst="rect">
             <a:avLst/>
@@ -2935,7 +2935,7 @@
               <a:buNone/>
             </a:pPr>
             <a:r>
-              <a:rPr lang="en-US" sz="1600" b="1" dirty="0">
+              <a:rPr lang="en-US" sz="1500" b="1" dirty="0">
                 <a:solidFill>
                   <a:srgbClr val="12163A"/>
                 </a:solidFill>
@@ -2945,7 +2945,7 @@
               </a:rPr>
               <a:t>3</a:t>
             </a:r>
-            <a:endParaRPr lang="en-US" sz="1600" dirty="0"/>
+            <a:endParaRPr lang="en-US" sz="1500" dirty="0"/>
           </a:p>
         </p:txBody>
       </p:sp>
@@ -2957,12 +2957,12 @@
         </p:nvSpPr>
         <p:spPr>
           <a:xfrm>
-            <a:off x="1188720" y="3319272"/>
-            <a:ext cx="10424160" cy="896112"/>
+            <a:off x="1170432" y="3017520"/>
+            <a:ext cx="10442448" cy="749808"/>
           </a:xfrm>
           <a:prstGeom prst="roundRect">
             <a:avLst>
-              <a:gd name="adj" fmla="val 9184"/>
+              <a:gd name="adj" fmla="val 10976"/>
             </a:avLst>
           </a:prstGeom>
           <a:solidFill>
@@ -2979,8 +2979,8 @@
         </p:nvSpPr>
         <p:spPr>
           <a:xfrm>
-            <a:off x="1417320" y="3392424"/>
-            <a:ext cx="10058400" cy="365760"/>
+            <a:off x="1399032" y="3081528"/>
+            <a:ext cx="10058400" cy="320040"/>
           </a:xfrm>
           <a:prstGeom prst="rect">
             <a:avLst/>
@@ -2996,7 +2996,7 @@
               <a:buNone/>
             </a:pPr>
             <a:r>
-              <a:rPr lang="en-US" sz="1400" b="1" dirty="0">
+              <a:rPr lang="en-US" sz="1350" b="1" dirty="0">
                 <a:solidFill>
                   <a:srgbClr val="F5F7FF"/>
                 </a:solidFill>
@@ -3006,7 +3006,7 @@
               </a:rPr>
               <a:t>“How does that compare with the month before?” (same session)</a:t>
             </a:r>
-            <a:endParaRPr lang="en-US" sz="1400" dirty="0"/>
+            <a:endParaRPr lang="en-US" sz="1350" dirty="0"/>
           </a:p>
         </p:txBody>
       </p:sp>
@@ -3018,8 +3018,8 @@
         </p:nvSpPr>
         <p:spPr>
           <a:xfrm>
-            <a:off x="1417320" y="3749040"/>
-            <a:ext cx="10058400" cy="411480"/>
+            <a:off x="1399032" y="3392424"/>
+            <a:ext cx="10058400" cy="347472"/>
           </a:xfrm>
           <a:prstGeom prst="rect">
             <a:avLst/>
@@ -3033,12 +3033,12 @@
           <a:p>
             <a:pPr indent="0" marL="0">
               <a:lnSpc>
-                <a:spcPct val="105000"/>
+                <a:spcPct val="102000"/>
               </a:lnSpc>
               <a:buNone/>
             </a:pPr>
             <a:r>
-              <a:rPr lang="en-US" sz="1150" dirty="0">
+              <a:rPr lang="en-US" sz="1100" dirty="0">
                 <a:solidFill>
                   <a:srgbClr val="CADCFC"/>
                 </a:solidFill>
@@ -3048,7 +3048,7 @@
               </a:rPr>
               <a:t>The biggest move is BIG BAZAAR RETAIL, up ₹1,13,26,049 — no context repeated in the follow-up question.</a:t>
             </a:r>
-            <a:endParaRPr lang="en-US" sz="1150" dirty="0"/>
+            <a:endParaRPr lang="en-US" sz="1100" dirty="0"/>
           </a:p>
         </p:txBody>
       </p:sp>
@@ -3060,8 +3060,8 @@
         </p:nvSpPr>
         <p:spPr>
           <a:xfrm>
-            <a:off x="548640" y="4343400"/>
-            <a:ext cx="457200" cy="457200"/>
+            <a:off x="548640" y="3904488"/>
+            <a:ext cx="420624" cy="420624"/>
           </a:xfrm>
           <a:prstGeom prst="ellipse">
             <a:avLst/>
@@ -3080,8 +3080,8 @@
         </p:nvSpPr>
         <p:spPr>
           <a:xfrm>
-            <a:off x="548640" y="4343400"/>
-            <a:ext cx="457200" cy="457200"/>
+            <a:off x="548640" y="3904488"/>
+            <a:ext cx="420624" cy="420624"/>
           </a:xfrm>
           <a:prstGeom prst="rect">
             <a:avLst/>
@@ -3097,7 +3097,7 @@
               <a:buNone/>
             </a:pPr>
             <a:r>
-              <a:rPr lang="en-US" sz="1600" b="1" dirty="0">
+              <a:rPr lang="en-US" sz="1500" b="1" dirty="0">
                 <a:solidFill>
                   <a:srgbClr val="12163A"/>
                 </a:solidFill>
@@ -3107,7 +3107,7 @@
               </a:rPr>
               <a:t>4</a:t>
             </a:r>
-            <a:endParaRPr lang="en-US" sz="1600" dirty="0"/>
+            <a:endParaRPr lang="en-US" sz="1500" dirty="0"/>
           </a:p>
         </p:txBody>
       </p:sp>
@@ -3119,12 +3119,12 @@
         </p:nvSpPr>
         <p:spPr>
           <a:xfrm>
-            <a:off x="1188720" y="4270248"/>
-            <a:ext cx="10424160" cy="896112"/>
+            <a:off x="1170432" y="3840480"/>
+            <a:ext cx="10442448" cy="749808"/>
           </a:xfrm>
           <a:prstGeom prst="roundRect">
             <a:avLst>
-              <a:gd name="adj" fmla="val 9184"/>
+              <a:gd name="adj" fmla="val 10976"/>
             </a:avLst>
           </a:prstGeom>
           <a:solidFill>
@@ -3141,8 +3141,8 @@
         </p:nvSpPr>
         <p:spPr>
           <a:xfrm>
-            <a:off x="1417320" y="4343400"/>
-            <a:ext cx="10058400" cy="365760"/>
+            <a:off x="1399032" y="3904488"/>
+            <a:ext cx="10058400" cy="320040"/>
           </a:xfrm>
           <a:prstGeom prst="rect">
             <a:avLst/>
@@ -3158,7 +3158,7 @@
               <a:buNone/>
             </a:pPr>
             <a:r>
-              <a:rPr lang="en-US" sz="1400" b="1" dirty="0">
+              <a:rPr lang="en-US" sz="1350" b="1" dirty="0">
                 <a:solidFill>
                   <a:srgbClr val="F5F7FF"/>
                 </a:solidFill>
@@ -3168,7 +3168,7 @@
               </a:rPr>
               <a:t>“How much tax did I pay this year?”</a:t>
             </a:r>
-            <a:endParaRPr lang="en-US" sz="1400" dirty="0"/>
+            <a:endParaRPr lang="en-US" sz="1350" dirty="0"/>
           </a:p>
         </p:txBody>
       </p:sp>
@@ -3180,8 +3180,8 @@
         </p:nvSpPr>
         <p:spPr>
           <a:xfrm>
-            <a:off x="1417320" y="4700016"/>
-            <a:ext cx="10058400" cy="411480"/>
+            <a:off x="1399032" y="4215384"/>
+            <a:ext cx="10058400" cy="347472"/>
           </a:xfrm>
           <a:prstGeom prst="rect">
             <a:avLst/>
@@ -3195,12 +3195,12 @@
           <a:p>
             <a:pPr indent="0" marL="0">
               <a:lnSpc>
-                <a:spcPct val="105000"/>
+                <a:spcPct val="102000"/>
               </a:lnSpc>
               <a:buNone/>
             </a:pPr>
             <a:r>
-              <a:rPr lang="en-US" sz="1150" dirty="0">
+              <a:rPr lang="en-US" sz="1100" dirty="0">
                 <a:solidFill>
                   <a:srgbClr val="CADCFC"/>
                 </a:solidFill>
@@ -3210,7 +3210,7 @@
               </a:rPr>
               <a:t>Total for 2026-01-01 to 2026-12-31: ₹1,95,63,10,950 — a derived category, shown as derived.</a:t>
             </a:r>
-            <a:endParaRPr lang="en-US" sz="1150" dirty="0"/>
+            <a:endParaRPr lang="en-US" sz="1100" dirty="0"/>
           </a:p>
         </p:txBody>
       </p:sp>
@@ -3222,8 +3222,8 @@
         </p:nvSpPr>
         <p:spPr>
           <a:xfrm>
-            <a:off x="548640" y="5294376"/>
-            <a:ext cx="457200" cy="457200"/>
+            <a:off x="548640" y="4727448"/>
+            <a:ext cx="420624" cy="420624"/>
           </a:xfrm>
           <a:prstGeom prst="ellipse">
             <a:avLst/>
@@ -3242,8 +3242,8 @@
         </p:nvSpPr>
         <p:spPr>
           <a:xfrm>
-            <a:off x="548640" y="5294376"/>
-            <a:ext cx="457200" cy="457200"/>
+            <a:off x="548640" y="4727448"/>
+            <a:ext cx="420624" cy="420624"/>
           </a:xfrm>
           <a:prstGeom prst="rect">
             <a:avLst/>
@@ -3259,7 +3259,7 @@
               <a:buNone/>
             </a:pPr>
             <a:r>
-              <a:rPr lang="en-US" sz="1600" b="1" dirty="0">
+              <a:rPr lang="en-US" sz="1500" b="1" dirty="0">
                 <a:solidFill>
                   <a:srgbClr val="12163A"/>
                 </a:solidFill>
@@ -3269,7 +3269,7 @@
               </a:rPr>
               <a:t>5</a:t>
             </a:r>
-            <a:endParaRPr lang="en-US" sz="1600" dirty="0"/>
+            <a:endParaRPr lang="en-US" sz="1500" dirty="0"/>
           </a:p>
         </p:txBody>
       </p:sp>
@@ -3281,12 +3281,12 @@
         </p:nvSpPr>
         <p:spPr>
           <a:xfrm>
-            <a:off x="1188720" y="5221224"/>
-            <a:ext cx="10424160" cy="896112"/>
+            <a:off x="1170432" y="4663440"/>
+            <a:ext cx="10442448" cy="749808"/>
           </a:xfrm>
           <a:prstGeom prst="roundRect">
             <a:avLst>
-              <a:gd name="adj" fmla="val 9184"/>
+              <a:gd name="adj" fmla="val 10976"/>
             </a:avLst>
           </a:prstGeom>
           <a:solidFill>
@@ -3303,8 +3303,8 @@
         </p:nvSpPr>
         <p:spPr>
           <a:xfrm>
-            <a:off x="1417320" y="5294376"/>
-            <a:ext cx="10058400" cy="365760"/>
+            <a:off x="1399032" y="4727448"/>
+            <a:ext cx="10058400" cy="320040"/>
           </a:xfrm>
           <a:prstGeom prst="rect">
             <a:avLst/>
@@ -3320,7 +3320,7 @@
               <a:buNone/>
             </a:pPr>
             <a:r>
-              <a:rPr lang="en-US" sz="1400" b="1" dirty="0">
+              <a:rPr lang="en-US" sz="1350" b="1" dirty="0">
                 <a:solidFill>
                   <a:srgbClr val="F5F7FF"/>
                 </a:solidFill>
@@ -3330,7 +3330,7 @@
               </a:rPr>
               <a:t>“Which transactions are unreconciled?” — the money shot</a:t>
             </a:r>
-            <a:endParaRPr lang="en-US" sz="1400" dirty="0"/>
+            <a:endParaRPr lang="en-US" sz="1350" dirty="0"/>
           </a:p>
         </p:txBody>
       </p:sp>
@@ -3342,8 +3342,8 @@
         </p:nvSpPr>
         <p:spPr>
           <a:xfrm>
-            <a:off x="1417320" y="5650992"/>
-            <a:ext cx="10058400" cy="411480"/>
+            <a:off x="1399032" y="5038344"/>
+            <a:ext cx="10058400" cy="347472"/>
           </a:xfrm>
           <a:prstGeom prst="rect">
             <a:avLst/>
@@ -3357,12 +3357,12 @@
           <a:p>
             <a:pPr indent="0" marL="0">
               <a:lnSpc>
-                <a:spcPct val="105000"/>
+                <a:spcPct val="102000"/>
               </a:lnSpc>
               <a:buNone/>
             </a:pPr>
             <a:r>
-              <a:rPr lang="en-US" sz="1150" dirty="0">
+              <a:rPr lang="en-US" sz="1100" dirty="0">
                 <a:solidFill>
                   <a:srgbClr val="CADCFC"/>
                 </a:solidFill>
@@ -3372,7 +3372,7 @@
               </a:rPr>
               <a:t>“This dataset has no reconciliation status … I will not infer one.” Refuses cleanly in 0.007s.</a:t>
             </a:r>
-            <a:endParaRPr lang="en-US" sz="1150" dirty="0"/>
+            <a:endParaRPr lang="en-US" sz="1100" dirty="0"/>
           </a:p>
         </p:txBody>
       </p:sp>
@@ -3384,8 +3384,8 @@
         </p:nvSpPr>
         <p:spPr>
           <a:xfrm>
-            <a:off x="548640" y="6245352"/>
-            <a:ext cx="457200" cy="457200"/>
+            <a:off x="548640" y="5550408"/>
+            <a:ext cx="420624" cy="420624"/>
           </a:xfrm>
           <a:prstGeom prst="ellipse">
             <a:avLst/>
@@ -3404,8 +3404,8 @@
         </p:nvSpPr>
         <p:spPr>
           <a:xfrm>
-            <a:off x="548640" y="6245352"/>
-            <a:ext cx="457200" cy="457200"/>
+            <a:off x="548640" y="5550408"/>
+            <a:ext cx="420624" cy="420624"/>
           </a:xfrm>
           <a:prstGeom prst="rect">
             <a:avLst/>
@@ -3421,7 +3421,7 @@
               <a:buNone/>
             </a:pPr>
             <a:r>
-              <a:rPr lang="en-US" sz="1600" b="1" dirty="0">
+              <a:rPr lang="en-US" sz="1500" b="1" dirty="0">
                 <a:solidFill>
                   <a:srgbClr val="12163A"/>
                 </a:solidFill>
@@ -3431,7 +3431,7 @@
               </a:rPr>
               <a:t>6</a:t>
             </a:r>
-            <a:endParaRPr lang="en-US" sz="1600" dirty="0"/>
+            <a:endParaRPr lang="en-US" sz="1500" dirty="0"/>
           </a:p>
         </p:txBody>
       </p:sp>
@@ -3443,12 +3443,12 @@
         </p:nvSpPr>
         <p:spPr>
           <a:xfrm>
-            <a:off x="1188720" y="6172200"/>
-            <a:ext cx="10424160" cy="896112"/>
+            <a:off x="1170432" y="5486400"/>
+            <a:ext cx="10442448" cy="749808"/>
           </a:xfrm>
           <a:prstGeom prst="roundRect">
             <a:avLst>
-              <a:gd name="adj" fmla="val 9184"/>
+              <a:gd name="adj" fmla="val 10976"/>
             </a:avLst>
           </a:prstGeom>
           <a:solidFill>
@@ -3465,8 +3465,8 @@
         </p:nvSpPr>
         <p:spPr>
           <a:xfrm>
-            <a:off x="1417320" y="6245352"/>
-            <a:ext cx="10058400" cy="365760"/>
+            <a:off x="1399032" y="5550408"/>
+            <a:ext cx="10058400" cy="320040"/>
           </a:xfrm>
           <a:prstGeom prst="rect">
             <a:avLst/>
@@ -3482,7 +3482,7 @@
               <a:buNone/>
             </a:pPr>
             <a:r>
-              <a:rPr lang="en-US" sz="1400" b="1" dirty="0">
+              <a:rPr lang="en-US" sz="1350" b="1" dirty="0">
                 <a:solidFill>
                   <a:srgbClr val="F5F7FF"/>
                 </a:solidFill>
@@ -3492,7 +3492,7 @@
               </a:rPr>
               <a:t>GET /efficiency</a:t>
             </a:r>
-            <a:endParaRPr lang="en-US" sz="1400" dirty="0"/>
+            <a:endParaRPr lang="en-US" sz="1350" dirty="0"/>
           </a:p>
         </p:txBody>
       </p:sp>
@@ -3504,8 +3504,8 @@
         </p:nvSpPr>
         <p:spPr>
           <a:xfrm>
-            <a:off x="1417320" y="6601968"/>
-            <a:ext cx="10058400" cy="411480"/>
+            <a:off x="1399032" y="5861304"/>
+            <a:ext cx="10058400" cy="347472"/>
           </a:xfrm>
           <a:prstGeom prst="rect">
             <a:avLst/>
@@ -3519,12 +3519,12 @@
           <a:p>
             <a:pPr indent="0" marL="0">
               <a:lnSpc>
-                <a:spcPct val="105000"/>
+                <a:spcPct val="102000"/>
               </a:lnSpc>
               <a:buNone/>
             </a:pPr>
             <a:r>
-              <a:rPr lang="en-US" sz="1150" dirty="0">
+              <a:rPr lang="en-US" sz="1100" dirty="0">
                 <a:solidFill>
                   <a:srgbClr val="CADCFC"/>
                 </a:solidFill>
@@ -3534,7 +3534,7 @@
               </a:rPr>
               <a:t>Which model answered, and the escalation rate — the model-efficiency claim, live.</a:t>
             </a:r>
-            <a:endParaRPr lang="en-US" sz="1150" dirty="0"/>
+            <a:endParaRPr lang="en-US" sz="1100" dirty="0"/>
           </a:p>
         </p:txBody>
       </p:sp>

</xml_diff>

<commit_message>
Eval runner uses the API planner path; refreshed model efficiency numbers and deck
Co-Authored-By: Claude Fable 5.1 <noreply@anthropic.com>
</commit_message>
<xml_diff>
--- a/docs/deck.pptx
+++ b/docs/deck.pptx
@@ -225,10 +225,10 @@
                 <c:formatCode>General</c:formatCode>
                 <c:ptCount val="11"/>
                 <c:pt idx="0">
-                  <c:v>16</c:v>
+                  <c:v>18</c:v>
                 </c:pt>
                 <c:pt idx="1">
-                  <c:v>12</c:v>
+                  <c:v>14</c:v>
                 </c:pt>
                 <c:pt idx="2">
                   <c:v>11</c:v>
@@ -9615,7 +9615,7 @@
                 <a:ea typeface="Cambria" pitchFamily="34" charset="-122"/>
                 <a:cs typeface="Cambria" pitchFamily="34" charset="-120"/>
               </a:rPr>
-              <a:t>Model comparison — golden set (55 cases)</a:t>
+              <a:t>Model comparison — golden set (57 cases)</a:t>
             </a:r>
             <a:endParaRPr lang="en-US" sz="3200" dirty="0"/>
           </a:p>
@@ -10156,7 +10156,7 @@
                             <a:srgbClr val="CADCFC"/>
                           </a:solidFill>
                         </a:rPr>
-                        <a:t>54/55 (98%)</a:t>
+                        <a:t>57/57 (100%)</a:t>
                       </a:r>
                       <a:endParaRPr lang="en-US" sz="1200" dirty="0"/>
                     </a:p>
@@ -10278,7 +10278,7 @@
                             <a:srgbClr val="CADCFC"/>
                           </a:solidFill>
                         </a:rPr>
-                        <a:t>458 ms</a:t>
+                        <a:t>467 ms</a:t>
                       </a:r>
                       <a:endParaRPr lang="en-US" sz="1200" dirty="0"/>
                     </a:p>
@@ -10339,7 +10339,7 @@
                             <a:srgbClr val="CADCFC"/>
                           </a:solidFill>
                         </a:rPr>
-                        <a:t>3,546 ms</a:t>
+                        <a:t>736 ms</a:t>
                       </a:r>
                       <a:endParaRPr lang="en-US" sz="1200" dirty="0"/>
                     </a:p>
@@ -10524,7 +10524,7 @@
                             <a:srgbClr val="F5F7FF"/>
                           </a:solidFill>
                         </a:rPr>
-                        <a:t>55/55 (100%)</a:t>
+                        <a:t>57/57 (100%)</a:t>
                       </a:r>
                       <a:endParaRPr lang="en-US" sz="1200" dirty="0"/>
                     </a:p>
@@ -10646,7 +10646,7 @@
                             <a:srgbClr val="F5F7FF"/>
                           </a:solidFill>
                         </a:rPr>
-                        <a:t>1,517 ms</a:t>
+                        <a:t>1,378 ms</a:t>
                       </a:r>
                       <a:endParaRPr lang="en-US" sz="1200" dirty="0"/>
                     </a:p>
@@ -10707,7 +10707,7 @@
                             <a:srgbClr val="F5F7FF"/>
                           </a:solidFill>
                         </a:rPr>
-                        <a:t>7,502 ms</a:t>
+                        <a:t>2,480 ms</a:t>
                       </a:r>
                       <a:endParaRPr lang="en-US" sz="1200" dirty="0"/>
                     </a:p>
@@ -10770,7 +10770,7 @@
                             <a:srgbClr val="CADCFC"/>
                           </a:solidFill>
                         </a:rPr>
-                        <a:t>qwen3:8b  — escalation</a:t>
+                        <a:t>qwen3:8b — escalation (pre-fix)</a:t>
                       </a:r>
                       <a:endParaRPr lang="en-US" sz="1200" dirty="0"/>
                     </a:p>
@@ -11260,7 +11260,7 @@
                             <a:srgbClr val="CADCFC"/>
                           </a:solidFill>
                         </a:rPr>
-                        <a:t>55/55 (100%)</a:t>
+                        <a:t>57/57 (100%)</a:t>
                       </a:r>
                       <a:endParaRPr lang="en-US" sz="1200" dirty="0"/>
                     </a:p>
@@ -11382,7 +11382,7 @@
                             <a:srgbClr val="CADCFC"/>
                           </a:solidFill>
                         </a:rPr>
-                        <a:t>1,561 ms</a:t>
+                        <a:t>1,591 ms</a:t>
                       </a:r>
                       <a:endParaRPr lang="en-US" sz="1200" dirty="0"/>
                     </a:p>
@@ -11443,7 +11443,7 @@
                             <a:srgbClr val="CADCFC"/>
                           </a:solidFill>
                         </a:rPr>
-                        <a:t>7,600 ms</a:t>
+                        <a:t>16,330 ms</a:t>
                       </a:r>
                       <a:endParaRPr lang="en-US" sz="1200" dirty="0"/>
                     </a:p>
@@ -11628,7 +11628,7 @@
                             <a:srgbClr val="CADCFC"/>
                           </a:solidFill>
                         </a:rPr>
-                        <a:t>55/55 (100%)</a:t>
+                        <a:t>57/57 (100%)</a:t>
                       </a:r>
                       <a:endParaRPr lang="en-US" sz="1200" dirty="0"/>
                     </a:p>
@@ -11750,7 +11750,7 @@
                             <a:srgbClr val="CADCFC"/>
                           </a:solidFill>
                         </a:rPr>
-                        <a:t>1,533 ms</a:t>
+                        <a:t>4,399 ms</a:t>
                       </a:r>
                       <a:endParaRPr lang="en-US" sz="1200" dirty="0"/>
                     </a:p>
@@ -11811,7 +11811,7 @@
                             <a:srgbClr val="CADCFC"/>
                           </a:solidFill>
                         </a:rPr>
-                        <a:t>2,753 ms</a:t>
+                        <a:t>32,996 ms</a:t>
                       </a:r>
                       <a:endParaRPr lang="en-US" sz="1200" dirty="0"/>
                     </a:p>
@@ -11925,7 +11925,7 @@
                   <a:srgbClr val="00D2B4"/>
                 </a:solidFill>
               </a:rPr>
-              <a:t>qwen3:4b </a:t>
+              <a:t>qwen3:1.7b and qwen3:4b </a:t>
             </a:r>
             <a:pPr indent="0" marL="0">
               <a:lnSpc>
@@ -11939,7 +11939,7 @@
                   <a:srgbClr val="F5F7FF"/>
                 </a:solidFill>
               </a:rPr>
-              <a:t>is the pick: the only raw model at a clean 55/55, roughly 3.3× faster p50 than qwen3:8b. The escalation tier </a:t>
+              <a:t>are tied at 57/57 on the current golden set; qwen3:1.7b is now the committed default, at roughly 3x qwen3:4b’s p50. Self-consistency escalation </a:t>
             </a:r>
             <a:pPr indent="0" marL="0">
               <a:lnSpc>
@@ -11953,7 +11953,7 @@
                   <a:srgbClr val="F2A65A"/>
                 </a:solidFill>
               </a:rPr>
-              <a:t>never engaged</a:t>
+              <a:t>fires for the first time</a:t>
             </a:r>
             <a:pPr indent="0" marL="0">
               <a:lnSpc>
@@ -11967,7 +11967,7 @@
                   <a:srgbClr val="F5F7FF"/>
                 </a:solidFill>
               </a:rPr>
-              <a:t> on this golden set — 0 escalations in both tiered runs. qwen3:8b is not better here: it scored worse than 4b (54/55) while being both the largest and by far the slowest model (29s worst case).</a:t>
+              <a:t> once samples=3 (2/57, 4%), at 100% accuracy on the escalated cases. qwen3:8b’s 54/55 predates the golden-set fix and was not re-run, so it isn’t a like-for-like comparison here.</a:t>
             </a:r>
             <a:endParaRPr lang="en-US" sz="1350" dirty="0"/>
           </a:p>
@@ -12245,7 +12245,7 @@
                 <a:ea typeface="Cambria" pitchFamily="34" charset="-122"/>
                 <a:cs typeface="Cambria" pitchFamily="34" charset="-120"/>
               </a:rPr>
-              <a:t>55</a:t>
+              <a:t>57</a:t>
             </a:r>
             <a:endParaRPr lang="en-US" sz="3000" dirty="0"/>
           </a:p>
@@ -12355,7 +12355,7 @@
                 <a:ea typeface="Cambria" pitchFamily="34" charset="-122"/>
                 <a:cs typeface="Cambria" pitchFamily="34" charset="-120"/>
               </a:rPr>
-              <a:t>44/55</a:t>
+              <a:t>46/57</a:t>
             </a:r>
             <a:endParaRPr lang="en-US" sz="3000" dirty="0"/>
           </a:p>
@@ -12397,7 +12397,7 @@
                 <a:ea typeface="Calibri" pitchFamily="34" charset="-122"/>
                 <a:cs typeface="Calibri" pitchFamily="34" charset="-120"/>
               </a:rPr>
-              <a:t>answered by qwen3:4b (80%)</a:t>
+              <a:t>answered by qwen3:4b (81%)</a:t>
             </a:r>
             <a:endParaRPr lang="en-US" sz="1150" dirty="0"/>
           </a:p>
@@ -12465,7 +12465,7 @@
                 <a:ea typeface="Cambria" pitchFamily="34" charset="-122"/>
                 <a:cs typeface="Cambria" pitchFamily="34" charset="-120"/>
               </a:rPr>
-              <a:t>11/55</a:t>
+              <a:t>11/57</a:t>
             </a:r>
             <a:endParaRPr lang="en-US" sz="3000" dirty="0"/>
           </a:p>
@@ -12507,7 +12507,7 @@
                 <a:ea typeface="Calibri" pitchFamily="34" charset="-122"/>
                 <a:cs typeface="Calibri" pitchFamily="34" charset="-120"/>
               </a:rPr>
-              <a:t>refused before any model call (20%)</a:t>
+              <a:t>refused before any model call (19%)</a:t>
             </a:r>
             <a:endParaRPr lang="en-US" sz="1150" dirty="0"/>
           </a:p>
@@ -12656,7 +12656,7 @@
                 <a:ea typeface="Calibri" pitchFamily="34" charset="-122"/>
                 <a:cs typeface="Calibri" pitchFamily="34" charset="-120"/>
               </a:rPr>
-              <a:t>Tiered (default config) latency: p50 1,561 ms · max 7,600 ms</a:t>
+              <a:t>Tiered (default config) latency: p50 1,591 ms · max 16,330 ms</a:t>
             </a:r>
             <a:endParaRPr lang="en-US" sz="1300" dirty="0"/>
           </a:p>
@@ -12695,7 +12695,7 @@
                 <a:ea typeface="Calibri" pitchFamily="34" charset="-122"/>
                 <a:cs typeface="Calibri" pitchFamily="34" charset="-120"/>
               </a:rPr>
-              <a:t>GOLDEN SET COMPOSITION (TAGS, 55 CASES)</a:t>
+              <a:t>GOLDEN SET COMPOSITION (TAGS, 57 CASES)</a:t>
             </a:r>
             <a:endParaRPr lang="en-US" sz="1100" dirty="0"/>
           </a:p>
@@ -12779,7 +12779,7 @@
                   <a:srgbClr val="F2A65A"/>
                 </a:solidFill>
               </a:rPr>
-              <a:t>KNOWN GAP
+              <a:t>ESCALATION AT SAMPLES=1
 </a:t>
             </a:r>
             <a:endParaRPr lang="en-US" sz="1100" dirty="0"/>
@@ -12797,7 +12797,7 @@
                   <a:srgbClr val="F5F7FF"/>
                 </a:solidFill>
               </a:rPr>
-              <a:t>The self-consistency escalation path (plan_with_confidence) is exercised by </a:t>
+              <a:t>At the committed samples=1 default, a single self-consistency sample can’t disagree with itself, so escalation is structurally 0% here — not evidence the tier doesn’t work. The same </a:t>
             </a:r>
             <a:pPr indent="0" marL="0">
               <a:lnSpc>
@@ -12814,7 +12814,7 @@
                 <a:ea typeface="Courier New" pitchFamily="34" charset="-122"/>
                 <a:cs typeface="Courier New" pitchFamily="34" charset="-120"/>
               </a:rPr>
-              <a:t>/ask</a:t>
+              <a:t>plan_with_confidence</a:t>
             </a:r>
             <a:pPr indent="0" marL="0">
               <a:lnSpc>
@@ -12828,7 +12828,7 @@
                   <a:srgbClr val="F5F7FF"/>
                 </a:solidFill>
               </a:rPr>
-              <a:t>, not by this eval harness — so a 0% escalation rate here means “untested”, not “never needed”.</a:t>
+              <a:t> path escalates 2/57 cases (4%) once confidence.samples=3, at 100% accuracy on those cases — see the samples=3 comparison.</a:t>
             </a:r>
             <a:endParaRPr lang="en-US" sz="1100" dirty="0"/>
           </a:p>
@@ -14990,7 +14990,7 @@
                             <a:srgbClr val="CADCFC"/>
                           </a:solidFill>
                         </a:rPr>
-                        <a:t>16</a:t>
+                        <a:t>18</a:t>
                       </a:r>
                       <a:endParaRPr lang="en-US" sz="1150" dirty="0"/>
                     </a:p>
@@ -15051,7 +15051,7 @@
                             <a:srgbClr val="CADCFC"/>
                           </a:solidFill>
                         </a:rPr>
-                        <a:t>16/16</a:t>
+                        <a:t>18/18</a:t>
                       </a:r>
                       <a:endParaRPr lang="en-US" sz="1150" dirty="0"/>
                     </a:p>
@@ -15112,7 +15112,7 @@
                             <a:srgbClr val="CADCFC"/>
                           </a:solidFill>
                         </a:rPr>
-                        <a:t>16/16</a:t>
+                        <a:t>18/18</a:t>
                       </a:r>
                       <a:endParaRPr lang="en-US" sz="1150" dirty="0"/>
                     </a:p>
@@ -15234,7 +15234,7 @@
                             <a:srgbClr val="CADCFC"/>
                           </a:solidFill>
                         </a:rPr>
-                        <a:t>16/16</a:t>
+                        <a:t>18/18</a:t>
                       </a:r>
                       <a:endParaRPr lang="en-US" sz="1150" dirty="0"/>
                     </a:p>
@@ -15358,7 +15358,129 @@
                             <a:srgbClr val="CADCFC"/>
                           </a:solidFill>
                         </a:rPr>
-                        <a:t>12</a:t>
+                        <a:t>14</a:t>
+                      </a:r>
+                      <a:endParaRPr lang="en-US" sz="1150" dirty="0"/>
+                    </a:p>
+                  </a:txBody>
+                  <a:tcPr marL="91440" marR="91440" marT="45720" marB="45720" anchor="ctr">
+                    <a:lnL w="19050" cap="flat" cmpd="sng" algn="ctr">
+                      <a:solidFill>
+                        <a:srgbClr val="12163A"/>
+                      </a:solidFill>
+                      <a:prstDash val="solid"/>
+                      <a:round/>
+                      <a:headEnd type="none" w="med" len="med"/>
+                      <a:tailEnd type="none" w="med" len="med"/>
+                    </a:lnL>
+                    <a:lnR w="19050" cap="flat" cmpd="sng" algn="ctr">
+                      <a:solidFill>
+                        <a:srgbClr val="12163A"/>
+                      </a:solidFill>
+                      <a:prstDash val="solid"/>
+                      <a:round/>
+                      <a:headEnd type="none" w="med" len="med"/>
+                      <a:tailEnd type="none" w="med" len="med"/>
+                    </a:lnR>
+                    <a:lnT w="19050" cap="flat" cmpd="sng" algn="ctr">
+                      <a:solidFill>
+                        <a:srgbClr val="12163A"/>
+                      </a:solidFill>
+                      <a:prstDash val="solid"/>
+                      <a:round/>
+                      <a:headEnd type="none" w="med" len="med"/>
+                      <a:tailEnd type="none" w="med" len="med"/>
+                    </a:lnT>
+                    <a:lnB w="19050" cap="flat" cmpd="sng" algn="ctr">
+                      <a:solidFill>
+                        <a:srgbClr val="12163A"/>
+                      </a:solidFill>
+                      <a:prstDash val="solid"/>
+                      <a:round/>
+                      <a:headEnd type="none" w="med" len="med"/>
+                      <a:tailEnd type="none" w="med" len="med"/>
+                    </a:lnB>
+                    <a:solidFill>
+                      <a:srgbClr val="191F52"/>
+                    </a:solidFill>
+                  </a:tcPr>
+                </a:tc>
+                <a:tc>
+                  <a:txBody>
+                    <a:bodyPr/>
+                    <a:lstStyle/>
+                    <a:p>
+                      <a:pPr algn="ctr" indent="0" marL="0">
+                        <a:buNone/>
+                      </a:pPr>
+                      <a:r>
+                        <a:rPr lang="en-US" sz="1150" dirty="0">
+                          <a:solidFill>
+                            <a:srgbClr val="CADCFC"/>
+                          </a:solidFill>
+                        </a:rPr>
+                        <a:t>14/14</a:t>
+                      </a:r>
+                      <a:endParaRPr lang="en-US" sz="1150" dirty="0"/>
+                    </a:p>
+                  </a:txBody>
+                  <a:tcPr marL="91440" marR="91440" marT="45720" marB="45720" anchor="ctr">
+                    <a:lnL w="19050" cap="flat" cmpd="sng" algn="ctr">
+                      <a:solidFill>
+                        <a:srgbClr val="12163A"/>
+                      </a:solidFill>
+                      <a:prstDash val="solid"/>
+                      <a:round/>
+                      <a:headEnd type="none" w="med" len="med"/>
+                      <a:tailEnd type="none" w="med" len="med"/>
+                    </a:lnL>
+                    <a:lnR w="19050" cap="flat" cmpd="sng" algn="ctr">
+                      <a:solidFill>
+                        <a:srgbClr val="12163A"/>
+                      </a:solidFill>
+                      <a:prstDash val="solid"/>
+                      <a:round/>
+                      <a:headEnd type="none" w="med" len="med"/>
+                      <a:tailEnd type="none" w="med" len="med"/>
+                    </a:lnR>
+                    <a:lnT w="19050" cap="flat" cmpd="sng" algn="ctr">
+                      <a:solidFill>
+                        <a:srgbClr val="12163A"/>
+                      </a:solidFill>
+                      <a:prstDash val="solid"/>
+                      <a:round/>
+                      <a:headEnd type="none" w="med" len="med"/>
+                      <a:tailEnd type="none" w="med" len="med"/>
+                    </a:lnT>
+                    <a:lnB w="19050" cap="flat" cmpd="sng" algn="ctr">
+                      <a:solidFill>
+                        <a:srgbClr val="12163A"/>
+                      </a:solidFill>
+                      <a:prstDash val="solid"/>
+                      <a:round/>
+                      <a:headEnd type="none" w="med" len="med"/>
+                      <a:tailEnd type="none" w="med" len="med"/>
+                    </a:lnB>
+                    <a:solidFill>
+                      <a:srgbClr val="191F52"/>
+                    </a:solidFill>
+                  </a:tcPr>
+                </a:tc>
+                <a:tc>
+                  <a:txBody>
+                    <a:bodyPr/>
+                    <a:lstStyle/>
+                    <a:p>
+                      <a:pPr algn="ctr" indent="0" marL="0">
+                        <a:buNone/>
+                      </a:pPr>
+                      <a:r>
+                        <a:rPr lang="en-US" sz="1150" dirty="0">
+                          <a:solidFill>
+                            <a:srgbClr val="CADCFC"/>
+                          </a:solidFill>
+                        </a:rPr>
+                        <a:t>14/14</a:t>
                       </a:r>
                       <a:endParaRPr lang="en-US" sz="1150" dirty="0"/>
                     </a:p>
@@ -15480,129 +15602,7 @@
                             <a:srgbClr val="CADCFC"/>
                           </a:solidFill>
                         </a:rPr>
-                        <a:t>12/12</a:t>
-                      </a:r>
-                      <a:endParaRPr lang="en-US" sz="1150" dirty="0"/>
-                    </a:p>
-                  </a:txBody>
-                  <a:tcPr marL="91440" marR="91440" marT="45720" marB="45720" anchor="ctr">
-                    <a:lnL w="19050" cap="flat" cmpd="sng" algn="ctr">
-                      <a:solidFill>
-                        <a:srgbClr val="12163A"/>
-                      </a:solidFill>
-                      <a:prstDash val="solid"/>
-                      <a:round/>
-                      <a:headEnd type="none" w="med" len="med"/>
-                      <a:tailEnd type="none" w="med" len="med"/>
-                    </a:lnL>
-                    <a:lnR w="19050" cap="flat" cmpd="sng" algn="ctr">
-                      <a:solidFill>
-                        <a:srgbClr val="12163A"/>
-                      </a:solidFill>
-                      <a:prstDash val="solid"/>
-                      <a:round/>
-                      <a:headEnd type="none" w="med" len="med"/>
-                      <a:tailEnd type="none" w="med" len="med"/>
-                    </a:lnR>
-                    <a:lnT w="19050" cap="flat" cmpd="sng" algn="ctr">
-                      <a:solidFill>
-                        <a:srgbClr val="12163A"/>
-                      </a:solidFill>
-                      <a:prstDash val="solid"/>
-                      <a:round/>
-                      <a:headEnd type="none" w="med" len="med"/>
-                      <a:tailEnd type="none" w="med" len="med"/>
-                    </a:lnT>
-                    <a:lnB w="19050" cap="flat" cmpd="sng" algn="ctr">
-                      <a:solidFill>
-                        <a:srgbClr val="12163A"/>
-                      </a:solidFill>
-                      <a:prstDash val="solid"/>
-                      <a:round/>
-                      <a:headEnd type="none" w="med" len="med"/>
-                      <a:tailEnd type="none" w="med" len="med"/>
-                    </a:lnB>
-                    <a:solidFill>
-                      <a:srgbClr val="191F52"/>
-                    </a:solidFill>
-                  </a:tcPr>
-                </a:tc>
-                <a:tc>
-                  <a:txBody>
-                    <a:bodyPr/>
-                    <a:lstStyle/>
-                    <a:p>
-                      <a:pPr algn="ctr" indent="0" marL="0">
-                        <a:buNone/>
-                      </a:pPr>
-                      <a:r>
-                        <a:rPr lang="en-US" sz="1150" dirty="0">
-                          <a:solidFill>
-                            <a:srgbClr val="CADCFC"/>
-                          </a:solidFill>
-                        </a:rPr>
-                        <a:t>12/12</a:t>
-                      </a:r>
-                      <a:endParaRPr lang="en-US" sz="1150" dirty="0"/>
-                    </a:p>
-                  </a:txBody>
-                  <a:tcPr marL="91440" marR="91440" marT="45720" marB="45720" anchor="ctr">
-                    <a:lnL w="19050" cap="flat" cmpd="sng" algn="ctr">
-                      <a:solidFill>
-                        <a:srgbClr val="12163A"/>
-                      </a:solidFill>
-                      <a:prstDash val="solid"/>
-                      <a:round/>
-                      <a:headEnd type="none" w="med" len="med"/>
-                      <a:tailEnd type="none" w="med" len="med"/>
-                    </a:lnL>
-                    <a:lnR w="19050" cap="flat" cmpd="sng" algn="ctr">
-                      <a:solidFill>
-                        <a:srgbClr val="12163A"/>
-                      </a:solidFill>
-                      <a:prstDash val="solid"/>
-                      <a:round/>
-                      <a:headEnd type="none" w="med" len="med"/>
-                      <a:tailEnd type="none" w="med" len="med"/>
-                    </a:lnR>
-                    <a:lnT w="19050" cap="flat" cmpd="sng" algn="ctr">
-                      <a:solidFill>
-                        <a:srgbClr val="12163A"/>
-                      </a:solidFill>
-                      <a:prstDash val="solid"/>
-                      <a:round/>
-                      <a:headEnd type="none" w="med" len="med"/>
-                      <a:tailEnd type="none" w="med" len="med"/>
-                    </a:lnT>
-                    <a:lnB w="19050" cap="flat" cmpd="sng" algn="ctr">
-                      <a:solidFill>
-                        <a:srgbClr val="12163A"/>
-                      </a:solidFill>
-                      <a:prstDash val="solid"/>
-                      <a:round/>
-                      <a:headEnd type="none" w="med" len="med"/>
-                      <a:tailEnd type="none" w="med" len="med"/>
-                    </a:lnB>
-                    <a:solidFill>
-                      <a:srgbClr val="191F52"/>
-                    </a:solidFill>
-                  </a:tcPr>
-                </a:tc>
-                <a:tc>
-                  <a:txBody>
-                    <a:bodyPr/>
-                    <a:lstStyle/>
-                    <a:p>
-                      <a:pPr algn="ctr" indent="0" marL="0">
-                        <a:buNone/>
-                      </a:pPr>
-                      <a:r>
-                        <a:rPr lang="en-US" sz="1150" dirty="0">
-                          <a:solidFill>
-                            <a:srgbClr val="CADCFC"/>
-                          </a:solidFill>
-                        </a:rPr>
-                        <a:t>12/12</a:t>
+                        <a:t>14/14</a:t>
                       </a:r>
                       <a:endParaRPr lang="en-US" sz="1150" dirty="0"/>
                     </a:p>
@@ -15782,12 +15782,12 @@
                         <a:buNone/>
                       </a:pPr>
                       <a:r>
-                        <a:rPr lang="en-US" sz="1150" b="1" dirty="0">
+                        <a:rPr lang="en-US" sz="1150" dirty="0">
                           <a:solidFill>
-                            <a:srgbClr val="FF8A80"/>
+                            <a:srgbClr val="CADCFC"/>
                           </a:solidFill>
                         </a:rPr>
-                        <a:t>9/10</a:t>
+                        <a:t>10/10</a:t>
                       </a:r>
                       <a:endParaRPr lang="en-US" sz="1150" dirty="0"/>
                     </a:p>
@@ -16150,12 +16150,12 @@
                         <a:buNone/>
                       </a:pPr>
                       <a:r>
-                        <a:rPr lang="en-US" sz="1150" b="1" dirty="0">
+                        <a:rPr lang="en-US" sz="1150" dirty="0">
                           <a:solidFill>
-                            <a:srgbClr val="FF8A80"/>
+                            <a:srgbClr val="CADCFC"/>
                           </a:solidFill>
                         </a:rPr>
-                        <a:t>3/4</a:t>
+                        <a:t>4/4</a:t>
                       </a:r>
                       <a:endParaRPr lang="en-US" sz="1150" dirty="0"/>
                     </a:p>
@@ -17555,7 +17555,7 @@
                   <a:srgbClr val="CADCFC"/>
                 </a:solidFill>
               </a:rPr>
-              <a:t>across every configuration tested — including the two single misses shown in red (1.7b on a grouping spec, 8b on a date-range spec).</a:t>
+              <a:t>across every configuration on the current 57-case set. The one miss shown in red (qwen3:8b on a date-range spec) is from its pre-fix, 55-case run — not re-run here, so its row is not directly comparable to the others’ totals.</a:t>
             </a:r>
             <a:endParaRPr lang="en-US" sz="1300" dirty="0"/>
           </a:p>

</xml_diff>